<commit_message>
docs: update documentation, PPT presentation, terms & conditions, and error rectification details
</commit_message>
<xml_diff>
--- a/AI_Voice_Assistant_Presentation.pptx
+++ b/AI_Voice_Assistant_Presentation.pptx
@@ -14,7 +14,6 @@
     <p:sldId id="262" r:id="rId13"/>
     <p:sldId id="263" r:id="rId14"/>
     <p:sldId id="264" r:id="rId15"/>
-    <p:sldId id="265" r:id="rId16"/>
   </p:sldIdLst>
   <p:sldSz cx="12191695" cy="6858000" type="screen4x3"/>
   <p:notesSz cx="6858000" cy="9144000"/>
@@ -3148,8 +3147,8 @@
         </p:nvSpPr>
         <p:spPr>
           <a:xfrm>
-            <a:off x="914400" y="2011680"/>
-            <a:ext cx="10362895" cy="3200400"/>
+            <a:off x="914400" y="1828800"/>
+            <a:ext cx="10362895" cy="3474720"/>
           </a:xfrm>
           <a:prstGeom prst="rect">
             <a:avLst/>
@@ -3163,7 +3162,7 @@
           <a:lstStyle/>
           <a:p>
             <a:pPr algn="ctr">
-              <a:defRPr sz="4000" b="1">
+              <a:defRPr sz="3800" b="1">
                 <a:solidFill>
                   <a:srgbClr val="00F2FE"/>
                 </a:solidFill>
@@ -3176,7 +3175,7 @@
           </a:p>
           <a:p>
             <a:pPr algn="ctr">
-              <a:defRPr sz="2000">
+              <a:defRPr sz="1800">
                 <a:solidFill>
                   <a:srgbClr val="F0F6FC"/>
                 </a:solidFill>
@@ -3184,7 +3183,7 @@
               </a:defRPr>
             </a:pPr>
             <a:r>
-              <a:t>Speech Recognition, Text-to-Speech Synthesis &amp; Web Control Center</a:t>
+              <a:t>Speech Recognition, Google OAuth Sign-In, Email/Password Auth &amp; SQLite Database</a:t>
             </a:r>
           </a:p>
           <a:p>
@@ -3198,7 +3197,7 @@
               </a:defRPr>
             </a:pPr>
             <a:r>
-              <a:t>Major Academic Project Presentation  |  Python 3.13 • SpeechRecognition • pyttsx3 • Flask</a:t>
+              <a:t>Major Academic Project Presentation  |  Python 3.13 • SQLite3 • Google GIS • Flask</a:t>
             </a:r>
           </a:p>
         </p:txBody>
@@ -3211,7 +3210,7 @@
 </p:sld>
 </file>
 
-<file path=ppt/slides/slide10.xml><?xml version="1.0" encoding="utf-8"?>
+<file path=ppt/slides/slide2.xml><?xml version="1.0" encoding="utf-8"?>
 <p:sld xmlns:a="http://schemas.openxmlformats.org/drawingml/2006/main" xmlns:p="http://schemas.openxmlformats.org/presentationml/2006/main" xmlns:r="http://schemas.openxmlformats.org/officeDocument/2006/relationships">
   <p:cSld>
     <p:spTree>
@@ -3272,8 +3271,8 @@
         </p:nvSpPr>
         <p:spPr>
           <a:xfrm>
-            <a:off x="914400" y="2286000"/>
-            <a:ext cx="10362895" cy="2743200"/>
+            <a:off x="731520" y="457200"/>
+            <a:ext cx="10728655" cy="822960"/>
           </a:xfrm>
           <a:prstGeom prst="rect">
             <a:avLst/>
@@ -3286,8 +3285,8 @@
           </a:bodyPr>
           <a:lstStyle/>
           <a:p>
-            <a:pPr algn="ctr">
-              <a:defRPr sz="4800" b="1">
+            <a:pPr>
+              <a:defRPr sz="2800" b="1">
                 <a:solidFill>
                   <a:srgbClr val="00F2FE"/>
                 </a:solidFill>
@@ -3295,20 +3294,101 @@
               </a:defRPr>
             </a:pPr>
             <a:r>
-              <a:t>THANK YOU!</a:t>
-            </a:r>
-          </a:p>
-          <a:p>
-            <a:pPr algn="ctr">
-              <a:defRPr sz="2400">
-                <a:solidFill>
-                  <a:srgbClr val="F0F6FC"/>
-                </a:solidFill>
-                <a:latin typeface="Arial"/>
+              <a:t>Problem Statement &amp; Objectives</a:t>
+            </a:r>
+          </a:p>
+        </p:txBody>
+      </p:sp>
+      <p:sp>
+        <p:nvSpPr>
+          <p:cNvPr id="4" name="TextBox 3"/>
+          <p:cNvSpPr txBox="1"/>
+          <p:nvPr/>
+        </p:nvSpPr>
+        <p:spPr>
+          <a:xfrm>
+            <a:off x="731520" y="1371600"/>
+            <a:ext cx="10728655" cy="4937760"/>
+          </a:xfrm>
+          <a:prstGeom prst="rect">
+            <a:avLst/>
+          </a:prstGeom>
+          <a:noFill/>
+        </p:spPr>
+        <p:txBody>
+          <a:bodyPr wrap="square">
+            <a:spAutoFit/>
+          </a:bodyPr>
+          <a:lstStyle/>
+          <a:p/>
+          <a:p>
+            <a:pPr>
+              <a:defRPr sz="2000" b="1">
+                <a:solidFill>
+                  <a:srgbClr val="7F00FF"/>
+                </a:solidFill>
               </a:defRPr>
             </a:pPr>
             <a:r>
-              <a:t>Questions &amp; Answers (Q&amp;A)</a:t>
+              <a:t>Problem Statement</a:t>
+            </a:r>
+          </a:p>
+          <a:p>
+            <a:pPr>
+              <a:spcAft>
+                <a:spcPts val="1400"/>
+              </a:spcAft>
+              <a:defRPr sz="1500">
+                <a:solidFill>
+                  <a:srgbClr val="F0F6FC"/>
+                </a:solidFill>
+              </a:defRPr>
+            </a:pPr>
+            <a:r>
+              <a:t>Modern AI assistants require hands-free interaction, secure multi-user authentication, and persistent data storage. ARIA solves this by providing voice synthesis, desktop automation, Google OAuth, Email/Password auth, and an SQLite database.</a:t>
+            </a:r>
+          </a:p>
+          <a:p>
+            <a:pPr>
+              <a:defRPr sz="2000" b="1">
+                <a:solidFill>
+                  <a:srgbClr val="7F00FF"/>
+                </a:solidFill>
+              </a:defRPr>
+            </a:pPr>
+            <a:r>
+              <a:t>Key Objectives</a:t>
+            </a:r>
+          </a:p>
+          <a:p>
+            <a:pPr>
+              <a:spcAft>
+                <a:spcPts val="1400"/>
+              </a:spcAft>
+              <a:defRPr sz="1500">
+                <a:solidFill>
+                  <a:srgbClr val="F0F6FC"/>
+                </a:solidFill>
+              </a:defRPr>
+            </a:pPr>
+            <a:r>
+              <a:t>1. Google OAuth Sign-In &amp; Email/Password SQL authentication.</a:t>
+            </a:r>
+            <a:br/>
+            <a:r>
+              <a:t>2. Persistent user account &amp; chat history storage in SQLite database.</a:t>
+            </a:r>
+            <a:br/>
+            <a:r>
+              <a:t>3. Real-time microphone capture &amp; speech-to-text conversion.</a:t>
+            </a:r>
+            <a:br/>
+            <a:r>
+              <a:t>4. Offline voice response synthesis via pyttsx3 &amp; browser TTS.</a:t>
+            </a:r>
+            <a:br/>
+            <a:r>
+              <a:t>5. Automated system app launcher, math evaluator, and web search reports.</a:t>
             </a:r>
           </a:p>
         </p:txBody>
@@ -3321,7 +3401,7 @@
 </p:sld>
 </file>
 
-<file path=ppt/slides/slide2.xml><?xml version="1.0" encoding="utf-8"?>
+<file path=ppt/slides/slide3.xml><?xml version="1.0" encoding="utf-8"?>
 <p:sld xmlns:a="http://schemas.openxmlformats.org/drawingml/2006/main" xmlns:p="http://schemas.openxmlformats.org/presentationml/2006/main" xmlns:r="http://schemas.openxmlformats.org/officeDocument/2006/relationships">
   <p:cSld>
     <p:spTree>
@@ -3405,7 +3485,7 @@
               </a:defRPr>
             </a:pPr>
             <a:r>
-              <a:t>Problem Statement &amp; Objectives</a:t>
+              <a:t>Newest Added Features (Google Auth &amp; SQL DB)</a:t>
             </a:r>
           </a:p>
         </p:txBody>
@@ -3418,8 +3498,8 @@
         </p:nvSpPr>
         <p:spPr>
           <a:xfrm>
-            <a:off x="731520" y="1463040"/>
-            <a:ext cx="10728655" cy="4754880"/>
+            <a:off x="731520" y="1371600"/>
+            <a:ext cx="10728655" cy="4937760"/>
           </a:xfrm>
           <a:prstGeom prst="rect">
             <a:avLst/>
@@ -3434,72 +3514,94 @@
           <a:p/>
           <a:p>
             <a:pPr>
-              <a:defRPr sz="2000" b="1">
-                <a:solidFill>
-                  <a:srgbClr val="7F00FF"/>
-                </a:solidFill>
-              </a:defRPr>
+              <a:spcAft>
+                <a:spcPts val="1000"/>
+              </a:spcAft>
             </a:pPr>
             <a:r>
-              <a:t>Problem Statement</a:t>
+              <a:rPr b="1" sz="1700">
+                <a:solidFill>
+                  <a:srgbClr val="00F2FE"/>
+                </a:solidFill>
+              </a:rPr>
+              <a:t>- Google Sign-In OAuth System: </a:t>
+            </a:r>
+            <a:r>
+              <a:rPr sz="1400">
+                <a:solidFill>
+                  <a:srgbClr val="F0F6FC"/>
+                </a:solidFill>
+              </a:rPr>
+              <a:t>Official Google Identity Services (GIS SDK) integration. Supports 1-click Google Sign-In with JWT token decoding and profile picture sync.</a:t>
             </a:r>
           </a:p>
           <a:p>
             <a:pPr>
               <a:spcAft>
-                <a:spcPts val="1600"/>
+                <a:spcPts val="1000"/>
               </a:spcAft>
-              <a:defRPr sz="1500">
+            </a:pPr>
+            <a:r>
+              <a:rPr b="1" sz="1700">
+                <a:solidFill>
+                  <a:srgbClr val="00F2FE"/>
+                </a:solidFill>
+              </a:rPr>
+              <a:t>- Email &amp; Password Auth System: </a:t>
+            </a:r>
+            <a:r>
+              <a:rPr sz="1400">
                 <a:solidFill>
                   <a:srgbClr val="F0F6FC"/>
                 </a:solidFill>
-              </a:defRPr>
-            </a:pPr>
-            <a:r>
-              <a:t>Voice assistants enable users to perform tasks via spoken voice commands, boosting productivity and accessibility. This project builds a complete smart voice assistant simulating real-world AI capabilities.</a:t>
-            </a:r>
-          </a:p>
-          <a:p>
-            <a:pPr>
-              <a:defRPr sz="2000" b="1">
-                <a:solidFill>
-                  <a:srgbClr val="7F00FF"/>
-                </a:solidFill>
-              </a:defRPr>
-            </a:pPr>
-            <a:r>
-              <a:t>Key Objectives</a:t>
+              </a:rPr>
+              <a:t>Complete registration (/api/auth/register) and login (/api/auth/email-login). Password credentials protected with salted Werkzeug cryptographic hashes.</a:t>
             </a:r>
           </a:p>
           <a:p>
             <a:pPr>
               <a:spcAft>
-                <a:spcPts val="1600"/>
+                <a:spcPts val="1000"/>
               </a:spcAft>
-              <a:defRPr sz="1500">
+            </a:pPr>
+            <a:r>
+              <a:rPr b="1" sz="1700">
+                <a:solidFill>
+                  <a:srgbClr val="00F2FE"/>
+                </a:solidFill>
+              </a:rPr>
+              <a:t>- Persistent Relational SQL Database: </a:t>
+            </a:r>
+            <a:r>
+              <a:rPr sz="1400">
                 <a:solidFill>
                   <a:srgbClr val="F0F6FC"/>
                 </a:solidFill>
-              </a:defRPr>
+              </a:rPr>
+              <a:t>SQLite database (database.db) with structured tables: 'users' (accounts &amp; auth) and 'chat_history' (voice logs &amp; chat sessions).</a:t>
+            </a:r>
+          </a:p>
+          <a:p>
+            <a:pPr>
+              <a:spcAft>
+                <a:spcPts val="1000"/>
+              </a:spcAft>
             </a:pPr>
             <a:r>
-              <a:t>1. Capture real-time microphone audio and convert speech to text.</a:t>
-            </a:r>
-            <a:br/>
-            <a:r>
-              <a:t>2. Intelligently match and process voice command intent.</a:t>
-            </a:r>
-            <a:br/>
-            <a:r>
-              <a:t>3. Execute automated system actions (open apps, calculate math, check status).</a:t>
-            </a:r>
-            <a:br/>
-            <a:r>
-              <a:t>4. Deliver clear audible voice responses using offline TTS engine.</a:t>
-            </a:r>
-            <a:br/>
-            <a:r>
-              <a:t>5. Provide a high-aesthetic interactive web control center.</a:t>
+              <a:rPr b="1" sz="1700">
+                <a:solidFill>
+                  <a:srgbClr val="00F2FE"/>
+                </a:solidFill>
+              </a:rPr>
+              <a:t>- Auth Mode Switcher UI: </a:t>
+            </a:r>
+            <a:r>
+              <a:rPr sz="1400">
+                <a:solidFill>
+                  <a:srgbClr val="F0F6FC"/>
+                </a:solidFill>
+              </a:rPr>
+              <a:t>Interactive tabs to switch between 'Sign In' and 'Create Account' with instant status notifications and guest fallback.</a:t>
             </a:r>
           </a:p>
         </p:txBody>
@@ -3512,7 +3614,7 @@
 </p:sld>
 </file>
 
-<file path=ppt/slides/slide3.xml><?xml version="1.0" encoding="utf-8"?>
+<file path=ppt/slides/slide4.xml><?xml version="1.0" encoding="utf-8"?>
 <p:sld xmlns:a="http://schemas.openxmlformats.org/drawingml/2006/main" xmlns:p="http://schemas.openxmlformats.org/presentationml/2006/main" xmlns:r="http://schemas.openxmlformats.org/officeDocument/2006/relationships">
   <p:cSld>
     <p:spTree>
@@ -3596,7 +3698,7 @@
               </a:defRPr>
             </a:pPr>
             <a:r>
-              <a:t>System Architecture &amp; Technology Stack</a:t>
+              <a:t>SQL Relational Database Schema (database.db)</a:t>
             </a:r>
           </a:p>
         </p:txBody>
@@ -3609,8 +3711,8 @@
         </p:nvSpPr>
         <p:spPr>
           <a:xfrm>
-            <a:off x="731520" y="1463040"/>
-            <a:ext cx="10728655" cy="4754880"/>
+            <a:off x="731520" y="1371600"/>
+            <a:ext cx="10728655" cy="4937760"/>
           </a:xfrm>
           <a:prstGeom prst="rect">
             <a:avLst/>
@@ -3625,117 +3727,64 @@
           <a:p/>
           <a:p>
             <a:pPr>
-              <a:spcAft>
-                <a:spcPts val="1000"/>
-              </a:spcAft>
+              <a:defRPr sz="1900" b="1">
+                <a:solidFill>
+                  <a:srgbClr val="7F00FF"/>
+                </a:solidFill>
+              </a:defRPr>
             </a:pPr>
             <a:r>
-              <a:rPr b="1" sz="1700">
-                <a:solidFill>
-                  <a:srgbClr val="00F2FE"/>
-                </a:solidFill>
-              </a:rPr>
-              <a:t>- Python 3.13: </a:t>
-            </a:r>
-            <a:r>
-              <a:rPr sz="1500">
-                <a:solidFill>
-                  <a:srgbClr val="F0F6FC"/>
-                </a:solidFill>
-              </a:rPr>
-              <a:t>Core programming language for assistant engine, intent routing, and backend services.</a:t>
+              <a:t>Table 1: 'users' (User Accounts &amp; Auth)</a:t>
             </a:r>
           </a:p>
           <a:p>
             <a:pPr>
               <a:spcAft>
-                <a:spcPts val="1000"/>
+                <a:spcPts val="1600"/>
               </a:spcAft>
+              <a:defRPr sz="1400">
+                <a:solidFill>
+                  <a:srgbClr val="F0F6FC"/>
+                </a:solidFill>
+              </a:defRPr>
             </a:pPr>
             <a:r>
-              <a:rPr b="1" sz="1700">
-                <a:solidFill>
-                  <a:srgbClr val="00F2FE"/>
-                </a:solidFill>
-              </a:rPr>
-              <a:t>- SpeechRecognition &amp; PyAudio: </a:t>
-            </a:r>
-            <a:r>
-              <a:rPr sz="1500">
-                <a:solidFill>
-                  <a:srgbClr val="F0F6FC"/>
-                </a:solidFill>
-              </a:rPr>
-              <a:t>Handles real-time microphone stream capture and Google Speech-to-Text transcription.</a:t>
+              <a:t>Columns: id (PK), name, email (UNIQUE), password_hash (Werkzeug salted hash), provider ('Google'/'Email'), picture, created_at, last_login.</a:t>
+            </a:r>
+            <a:br/>
+            <a:r>
+              <a:t>Stores registered user credentials securely.</a:t>
+            </a:r>
+          </a:p>
+          <a:p>
+            <a:pPr>
+              <a:defRPr sz="1900" b="1">
+                <a:solidFill>
+                  <a:srgbClr val="7F00FF"/>
+                </a:solidFill>
+              </a:defRPr>
+            </a:pPr>
+            <a:r>
+              <a:t>Table 2: 'chat_history' (Conversation Logs)</a:t>
             </a:r>
           </a:p>
           <a:p>
             <a:pPr>
               <a:spcAft>
-                <a:spcPts val="1000"/>
+                <a:spcPts val="1600"/>
               </a:spcAft>
+              <a:defRPr sz="1400">
+                <a:solidFill>
+                  <a:srgbClr val="F0F6FC"/>
+                </a:solidFill>
+              </a:defRPr>
             </a:pPr>
             <a:r>
-              <a:rPr b="1" sz="1700">
-                <a:solidFill>
-                  <a:srgbClr val="00F2FE"/>
-                </a:solidFill>
-              </a:rPr>
-              <a:t>- pyttsx3 Voice Engine: </a:t>
-            </a:r>
-            <a:r>
-              <a:rPr sz="1500">
-                <a:solidFill>
-                  <a:srgbClr val="F0F6FC"/>
-                </a:solidFill>
-              </a:rPr>
-              <a:t>Offline text-to-speech synthesis engine providing natural audio feedback.</a:t>
-            </a:r>
-          </a:p>
-          <a:p>
-            <a:pPr>
-              <a:spcAft>
-                <a:spcPts val="1000"/>
-              </a:spcAft>
-            </a:pPr>
-            <a:r>
-              <a:rPr b="1" sz="1700">
-                <a:solidFill>
-                  <a:srgbClr val="00F2FE"/>
-                </a:solidFill>
-              </a:rPr>
-              <a:t>- Flask REST Framework: </a:t>
-            </a:r>
-            <a:r>
-              <a:rPr sz="1500">
-                <a:solidFill>
-                  <a:srgbClr val="F0F6FC"/>
-                </a:solidFill>
-              </a:rPr>
-              <a:t>Serves Web Control Center at http://localhost:5000 with REST API endpoints.</a:t>
-            </a:r>
-          </a:p>
-          <a:p>
-            <a:pPr>
-              <a:spcAft>
-                <a:spcPts val="1000"/>
-              </a:spcAft>
-            </a:pPr>
-            <a:r>
-              <a:rPr b="1" sz="1700">
-                <a:solidFill>
-                  <a:srgbClr val="00F2FE"/>
-                </a:solidFill>
-              </a:rPr>
-              <a:t>- HTML5, CSS3, JavaScript: </a:t>
-            </a:r>
-            <a:r>
-              <a:rPr sz="1500">
-                <a:solidFill>
-                  <a:srgbClr val="F0F6FC"/>
-                </a:solidFill>
-              </a:rPr>
-              <a:t>Futuristic Glassmorphic Dark UI, Web Audio API sound synth, and interactive modals.</a:t>
+              <a:t>Columns: id (PK AUTO), user_id (FK), session_id, role ('user'/'assistant'), message, category, timestamp.</a:t>
+            </a:r>
+            <a:br/>
+            <a:r>
+              <a:t>Persists user voice transcripts and assistant responses linked to individual account IDs.</a:t>
             </a:r>
           </a:p>
         </p:txBody>
@@ -3748,7 +3797,7 @@
 </p:sld>
 </file>
 
-<file path=ppt/slides/slide4.xml><?xml version="1.0" encoding="utf-8"?>
+<file path=ppt/slides/slide5.xml><?xml version="1.0" encoding="utf-8"?>
 <p:sld xmlns:a="http://schemas.openxmlformats.org/drawingml/2006/main" xmlns:p="http://schemas.openxmlformats.org/presentationml/2006/main" xmlns:r="http://schemas.openxmlformats.org/officeDocument/2006/relationships">
   <p:cSld>
     <p:spTree>
@@ -3832,7 +3881,7 @@
               </a:defRPr>
             </a:pPr>
             <a:r>
-              <a:t>Speech Recognition &amp; Response Pipeline</a:t>
+              <a:t>Terms and Conditions (Operational &amp; Privacy)</a:t>
             </a:r>
           </a:p>
         </p:txBody>
@@ -3845,8 +3894,8 @@
         </p:nvSpPr>
         <p:spPr>
           <a:xfrm>
-            <a:off x="731520" y="1463040"/>
-            <a:ext cx="10728655" cy="4754880"/>
+            <a:off x="731520" y="1371600"/>
+            <a:ext cx="10728655" cy="4937760"/>
           </a:xfrm>
           <a:prstGeom prst="rect">
             <a:avLst/>
@@ -3862,7 +3911,7 @@
           <a:p>
             <a:pPr>
               <a:spcAft>
-                <a:spcPts val="800"/>
+                <a:spcPts val="1000"/>
               </a:spcAft>
             </a:pPr>
             <a:r>
@@ -3871,7 +3920,7 @@
                   <a:srgbClr val="00F2FE"/>
                 </a:solidFill>
               </a:rPr>
-              <a:t>Step 1: Audio Input Capture -&gt; </a:t>
+              <a:t>- User Privacy &amp; Password Hashing: </a:t>
             </a:r>
             <a:r>
               <a:rPr sz="1400">
@@ -3879,13 +3928,13 @@
                   <a:srgbClr val="F0F6FC"/>
                 </a:solidFill>
               </a:rPr>
-              <a:t>Microphone stream captured via PyAudio (31 channels supported) or Browser Web Audio API.</a:t>
+              <a:t>Passwords are strictly stored as one-way PBKDF2/SHA-256 hashes. Google OAuth tokens are processed solely for identification and account linkage.</a:t>
             </a:r>
           </a:p>
           <a:p>
             <a:pPr>
               <a:spcAft>
-                <a:spcPts val="800"/>
+                <a:spcPts val="1000"/>
               </a:spcAft>
             </a:pPr>
             <a:r>
@@ -3894,7 +3943,7 @@
                   <a:srgbClr val="00F2FE"/>
                 </a:solidFill>
               </a:rPr>
-              <a:t>Step 2: Speech-to-Text (STT) -&gt; </a:t>
+              <a:t>- Microphone Stream Usage: </a:t>
             </a:r>
             <a:r>
               <a:rPr sz="1400">
@@ -3902,13 +3951,13 @@
                   <a:srgbClr val="F0F6FC"/>
                 </a:solidFill>
               </a:rPr>
-              <a:t>Audio processed by SpeechRecognition engine converting vocal waveform into text transcript.</a:t>
+              <a:t>Microphone audio is transcribed locally or via browser Web Speech API solely for command execution. Raw audio streams are never stored permanently without consent.</a:t>
             </a:r>
           </a:p>
           <a:p>
             <a:pPr>
               <a:spcAft>
-                <a:spcPts val="800"/>
+                <a:spcPts val="1000"/>
               </a:spcAft>
             </a:pPr>
             <a:r>
@@ -3917,7 +3966,7 @@
                   <a:srgbClr val="00F2FE"/>
                 </a:solidFill>
               </a:rPr>
-              <a:t>Step 3: Intent Routing -&gt; </a:t>
+              <a:t>- Account Confidentiality: </a:t>
             </a:r>
             <a:r>
               <a:rPr sz="1400">
@@ -3925,13 +3974,13 @@
                   <a:srgbClr val="F0F6FC"/>
                 </a:solidFill>
               </a:rPr>
-              <a:t>Pattern matching routes text to specific module (Time, Math, App Launcher, Web Search).</a:t>
+              <a:t>Users are responsible for maintaining credential secrecy. Chat history logs are strictly linked to user IDs in the SQLite database to preserve session privacy.</a:t>
             </a:r>
           </a:p>
           <a:p>
             <a:pPr>
               <a:spcAft>
-                <a:spcPts val="800"/>
+                <a:spcPts val="1000"/>
               </a:spcAft>
             </a:pPr>
             <a:r>
@@ -3940,7 +3989,7 @@
                   <a:srgbClr val="00F2FE"/>
                 </a:solidFill>
               </a:rPr>
-              <a:t>Step 4: Action Execution -&gt; </a:t>
+              <a:t>- Service Availability &amp; Rate Limits: </a:t>
             </a:r>
             <a:r>
               <a:rPr sz="1400">
@@ -3948,30 +3997,7 @@
                   <a:srgbClr val="F0F6FC"/>
                 </a:solidFill>
               </a:rPr>
-              <a:t>Launches local app, computes math, queries Wikipedia, or fetches Google Search Reports.</a:t>
-            </a:r>
-          </a:p>
-          <a:p>
-            <a:pPr>
-              <a:spcAft>
-                <a:spcPts val="800"/>
-              </a:spcAft>
-            </a:pPr>
-            <a:r>
-              <a:rPr b="1" sz="1600">
-                <a:solidFill>
-                  <a:srgbClr val="00F2FE"/>
-                </a:solidFill>
-              </a:rPr>
-              <a:t>Step 5: Spoken Audio Response -&gt; </a:t>
-            </a:r>
-            <a:r>
-              <a:rPr sz="1400">
-                <a:solidFill>
-                  <a:srgbClr val="F0F6FC"/>
-                </a:solidFill>
-              </a:rPr>
-              <a:t>Response spoken out loud orally via pyttsx3 host speakers and Web Speech Synthesis.</a:t>
+              <a:t>External API services (Wikipedia API, Google Search) are accessed within rate limits to ensure robust uptime and prevent service degradation.</a:t>
             </a:r>
           </a:p>
         </p:txBody>
@@ -3984,7 +4010,7 @@
 </p:sld>
 </file>
 
-<file path=ppt/slides/slide5.xml><?xml version="1.0" encoding="utf-8"?>
+<file path=ppt/slides/slide6.xml><?xml version="1.0" encoding="utf-8"?>
 <p:sld xmlns:a="http://schemas.openxmlformats.org/drawingml/2006/main" xmlns:p="http://schemas.openxmlformats.org/presentationml/2006/main" xmlns:r="http://schemas.openxmlformats.org/officeDocument/2006/relationships">
   <p:cSld>
     <p:spTree>
@@ -4068,7 +4094,7 @@
               </a:defRPr>
             </a:pPr>
             <a:r>
-              <a:t>Core Functional Features</a:t>
+              <a:t>Error Rectification &amp; Diagnostics</a:t>
             </a:r>
           </a:p>
         </p:txBody>
@@ -4081,8 +4107,8 @@
         </p:nvSpPr>
         <p:spPr>
           <a:xfrm>
-            <a:off x="731520" y="1463040"/>
-            <a:ext cx="10728655" cy="4754880"/>
+            <a:off x="731520" y="1371600"/>
+            <a:ext cx="10728655" cy="4937760"/>
           </a:xfrm>
           <a:prstGeom prst="rect">
             <a:avLst/>
@@ -4098,91 +4124,93 @@
           <a:p>
             <a:pPr>
               <a:spcAft>
-                <a:spcPts val="1200"/>
+                <a:spcPts val="1000"/>
               </a:spcAft>
-              <a:defRPr sz="1700">
+            </a:pPr>
+            <a:r>
+              <a:rPr b="1" sz="1600">
+                <a:solidFill>
+                  <a:srgbClr val="10B981"/>
+                </a:solidFill>
+              </a:rPr>
+              <a:t>[FIXED] Database Schema Migration Rectification: </a:t>
+            </a:r>
+            <a:r>
+              <a:rPr sz="1400">
                 <a:solidFill>
                   <a:srgbClr val="F0F6FC"/>
                 </a:solidFill>
-              </a:defRPr>
-            </a:pPr>
-            <a:r>
-              <a:t>[TIME] Time &amp; Date Engine: Tells current time and date in formatted 12-hour AM/PM format.</a:t>
+              </a:rPr>
+              <a:t>Added automatic PRAGMA table_info inspections and ALTER TABLE migrations in app.py to prevent 'missing column' crashes on legacy DB files.</a:t>
             </a:r>
           </a:p>
           <a:p>
             <a:pPr>
               <a:spcAft>
-                <a:spcPts val="1200"/>
+                <a:spcPts val="1000"/>
               </a:spcAft>
-              <a:defRPr sz="1700">
+            </a:pPr>
+            <a:r>
+              <a:rPr b="1" sz="1600">
+                <a:solidFill>
+                  <a:srgbClr val="10B981"/>
+                </a:solidFill>
+              </a:rPr>
+              <a:t>[FIXED] Credential Validation Rectification: </a:t>
+            </a:r>
+            <a:r>
+              <a:rPr sz="1400">
                 <a:solidFill>
                   <a:srgbClr val="F0F6FC"/>
                 </a:solidFill>
-              </a:defRPr>
-            </a:pPr>
-            <a:r>
-              <a:t>[APPS] System App Launcher: Launches Notepad, Calculator, Command Prompt, MS Paint, and Explorer.</a:t>
+              </a:rPr>
+              <a:t>Enforced password length constraints, duplicate email checks, and 401 Unauthorized responses to prevent corrupt database entries.</a:t>
             </a:r>
           </a:p>
           <a:p>
             <a:pPr>
               <a:spcAft>
-                <a:spcPts val="1200"/>
+                <a:spcPts val="1000"/>
               </a:spcAft>
-              <a:defRPr sz="1700">
+            </a:pPr>
+            <a:r>
+              <a:rPr b="1" sz="1600">
+                <a:solidFill>
+                  <a:srgbClr val="10B981"/>
+                </a:solidFill>
+              </a:rPr>
+              <a:t>[FIXED] Google OAuth Popup Block Fallback: </a:t>
+            </a:r>
+            <a:r>
+              <a:rPr sz="1400">
                 <a:solidFill>
                   <a:srgbClr val="F0F6FC"/>
                 </a:solidFill>
-              </a:defRPr>
-            </a:pPr>
-            <a:r>
-              <a:t>[MATH] Math Solver: Solves complex mathematical word problems and algebraic expressions.</a:t>
+              </a:rPr>
+              <a:t>Handled GIS SDK popup blockages with an interactive prompt dialog fallback so users can always sign in smoothly.</a:t>
             </a:r>
           </a:p>
           <a:p>
             <a:pPr>
               <a:spcAft>
-                <a:spcPts val="1200"/>
+                <a:spcPts val="1000"/>
               </a:spcAft>
-              <a:defRPr sz="1700">
+            </a:pPr>
+            <a:r>
+              <a:rPr b="1" sz="1600">
+                <a:solidFill>
+                  <a:srgbClr val="10B981"/>
+                </a:solidFill>
+              </a:rPr>
+              <a:t>[FIXED] Web Speech Permission Error Handling: </a:t>
+            </a:r>
+            <a:r>
+              <a:rPr sz="1400">
                 <a:solidFill>
                   <a:srgbClr val="F0F6FC"/>
                 </a:solidFill>
-              </a:defRPr>
-            </a:pPr>
-            <a:r>
-              <a:t>[SEARCH] Search Reports: Extracts Wikipedia summaries and multi-topic Google Search Reports.</a:t>
-            </a:r>
-          </a:p>
-          <a:p>
-            <a:pPr>
-              <a:spcAft>
-                <a:spcPts val="1200"/>
-              </a:spcAft>
-              <a:defRPr sz="1700">
-                <a:solidFill>
-                  <a:srgbClr val="F0F6FC"/>
-                </a:solidFill>
-              </a:defRPr>
-            </a:pPr>
-            <a:r>
-              <a:t>[STATS] System Stats: Live monitoring of host CPU load percentage and RAM utilization.</a:t>
-            </a:r>
-          </a:p>
-          <a:p>
-            <a:pPr>
-              <a:spcAft>
-                <a:spcPts val="1200"/>
-              </a:spcAft>
-              <a:defRPr sz="1700">
-                <a:solidFill>
-                  <a:srgbClr val="F0F6FC"/>
-                </a:solidFill>
-              </a:defRPr>
-            </a:pPr>
-            <a:r>
-              <a:t>[JOKES] Entertainment: Generates humorous programming and general jokes via pyjokes.</a:t>
+              </a:rPr>
+              <a:t>Handled 'not-allowed' microphone errors by seamlessly falling back to keyboard command input with clear visual UI alerts.</a:t>
             </a:r>
           </a:p>
         </p:txBody>
@@ -4195,7 +4223,7 @@
 </p:sld>
 </file>
 
-<file path=ppt/slides/slide6.xml><?xml version="1.0" encoding="utf-8"?>
+<file path=ppt/slides/slide7.xml><?xml version="1.0" encoding="utf-8"?>
 <p:sld xmlns:a="http://schemas.openxmlformats.org/drawingml/2006/main" xmlns:p="http://schemas.openxmlformats.org/presentationml/2006/main" xmlns:r="http://schemas.openxmlformats.org/officeDocument/2006/relationships">
   <p:cSld>
     <p:spTree>
@@ -4279,7 +4307,7 @@
               </a:defRPr>
             </a:pPr>
             <a:r>
-              <a:t>Ultra-Interactive Web Control Center UI</a:t>
+              <a:t>Technology Stack</a:t>
             </a:r>
           </a:p>
         </p:txBody>
@@ -4292,8 +4320,8 @@
         </p:nvSpPr>
         <p:spPr>
           <a:xfrm>
-            <a:off x="731520" y="1463040"/>
-            <a:ext cx="10728655" cy="4754880"/>
+            <a:off x="731520" y="1371600"/>
+            <a:ext cx="10728655" cy="4937760"/>
           </a:xfrm>
           <a:prstGeom prst="rect">
             <a:avLst/>
@@ -4309,116 +4337,139 @@
           <a:p>
             <a:pPr>
               <a:spcAft>
-                <a:spcPts val="1000"/>
+                <a:spcPts val="800"/>
               </a:spcAft>
             </a:pPr>
             <a:r>
-              <a:rPr b="1" sz="1700">
+              <a:rPr b="1" sz="1600">
                 <a:solidFill>
                   <a:srgbClr val="00F2FE"/>
                 </a:solidFill>
               </a:rPr>
-              <a:t>- Glassmorphic Dark Mode: </a:t>
-            </a:r>
-            <a:r>
-              <a:rPr sz="1500">
+              <a:t>- Python 3.13: </a:t>
+            </a:r>
+            <a:r>
+              <a:rPr sz="1400">
                 <a:solidFill>
                   <a:srgbClr val="F0F6FC"/>
                 </a:solidFill>
               </a:rPr>
-              <a:t>Futuristic neon layout with self-contained SVG graphics and smooth animations.</a:t>
+              <a:t>Core backend language for assistant engine, intent routing, and API endpoints.</a:t>
             </a:r>
           </a:p>
           <a:p>
             <a:pPr>
               <a:spcAft>
-                <a:spcPts val="1000"/>
+                <a:spcPts val="800"/>
               </a:spcAft>
             </a:pPr>
             <a:r>
-              <a:rPr b="1" sz="1700">
+              <a:rPr b="1" sz="1600">
                 <a:solidFill>
                   <a:srgbClr val="00F2FE"/>
                 </a:solidFill>
               </a:rPr>
-              <a:t>- Canvas Audio Visualizer: </a:t>
-            </a:r>
-            <a:r>
-              <a:rPr sz="1500">
+              <a:t>- SQLite 3 Database: </a:t>
+            </a:r>
+            <a:r>
+              <a:rPr sz="1400">
                 <a:solidFill>
                   <a:srgbClr val="F0F6FC"/>
                 </a:solidFill>
               </a:rPr>
-              <a:t>Dynamic audio spectrum visualizer animating live voice waveforms.</a:t>
+              <a:t>Persistent SQL database engine storing user credentials and conversation sessions.</a:t>
             </a:r>
           </a:p>
           <a:p>
             <a:pPr>
               <a:spcAft>
-                <a:spcPts val="1000"/>
+                <a:spcPts val="800"/>
               </a:spcAft>
             </a:pPr>
             <a:r>
-              <a:rPr b="1" sz="1700">
+              <a:rPr b="1" sz="1600">
                 <a:solidFill>
                   <a:srgbClr val="00F2FE"/>
                 </a:solidFill>
               </a:rPr>
-              <a:t>- Top Hero Result Banner: </a:t>
-            </a:r>
-            <a:r>
-              <a:rPr sz="1500">
+              <a:t>- Google Identity Services SDK: </a:t>
+            </a:r>
+            <a:r>
+              <a:rPr sz="1400">
                 <a:solidFill>
                   <a:srgbClr val="F0F6FC"/>
                 </a:solidFill>
               </a:rPr>
-              <a:t>Prominent display card rendering instant AI text answers and web links right below input.</a:t>
+              <a:t>Official Google OAuth 2.0 single sign-on authentication SDK.</a:t>
             </a:r>
           </a:p>
           <a:p>
             <a:pPr>
               <a:spcAft>
-                <a:spcPts val="1000"/>
+                <a:spcPts val="800"/>
               </a:spcAft>
             </a:pPr>
             <a:r>
-              <a:rPr b="1" sz="1700">
+              <a:rPr b="1" sz="1600">
                 <a:solidFill>
                   <a:srgbClr val="00F2FE"/>
                 </a:solidFill>
               </a:rPr>
-              <a:t>- Web Audio Synthesizer: </a:t>
-            </a:r>
-            <a:r>
-              <a:rPr sz="1500">
+              <a:t>- SpeechRecognition &amp; pyttsx3: </a:t>
+            </a:r>
+            <a:r>
+              <a:rPr sz="1400">
                 <a:solidFill>
                   <a:srgbClr val="F0F6FC"/>
                 </a:solidFill>
               </a:rPr>
-              <a:t>Generates acoustic feedback beeps and success chimes using Web Audio API oscillator tones.</a:t>
+              <a:t>Captures microphone speech and synthesizes offline spoken audio feedback.</a:t>
             </a:r>
           </a:p>
           <a:p>
             <a:pPr>
               <a:spcAft>
-                <a:spcPts val="1000"/>
+                <a:spcPts val="800"/>
               </a:spcAft>
             </a:pPr>
             <a:r>
-              <a:rPr b="1" sz="1700">
+              <a:rPr b="1" sz="1600">
                 <a:solidFill>
                   <a:srgbClr val="00F2FE"/>
                 </a:solidFill>
               </a:rPr>
-              <a:t>- Real-time Gauges: </a:t>
-            </a:r>
-            <a:r>
-              <a:rPr sz="1500">
+              <a:t>- Flask REST Framework: </a:t>
+            </a:r>
+            <a:r>
+              <a:rPr sz="1400">
                 <a:solidFill>
                   <a:srgbClr val="F0F6FC"/>
                 </a:solidFill>
               </a:rPr>
-              <a:t>Dynamic animated progress gauges for host CPU load and RAM usage.</a:t>
+              <a:t>Serves Web Control Center REST API at http://localhost:5000.</a:t>
+            </a:r>
+          </a:p>
+          <a:p>
+            <a:pPr>
+              <a:spcAft>
+                <a:spcPts val="800"/>
+              </a:spcAft>
+            </a:pPr>
+            <a:r>
+              <a:rPr b="1" sz="1600">
+                <a:solidFill>
+                  <a:srgbClr val="00F2FE"/>
+                </a:solidFill>
+              </a:rPr>
+              <a:t>- HTML5, CSS3, JavaScript: </a:t>
+            </a:r>
+            <a:r>
+              <a:rPr sz="1400">
+                <a:solidFill>
+                  <a:srgbClr val="F0F6FC"/>
+                </a:solidFill>
+              </a:rPr>
+              <a:t>Futuristic Glassmorphic Dark UI, Web Audio API sound effects, and interactive modals.</a:t>
             </a:r>
           </a:p>
         </p:txBody>
@@ -4431,7 +4482,7 @@
 </p:sld>
 </file>
 
-<file path=ppt/slides/slide7.xml><?xml version="1.0" encoding="utf-8"?>
+<file path=ppt/slides/slide8.xml><?xml version="1.0" encoding="utf-8"?>
 <p:sld xmlns:a="http://schemas.openxmlformats.org/drawingml/2006/main" xmlns:p="http://schemas.openxmlformats.org/presentationml/2006/main" xmlns:r="http://schemas.openxmlformats.org/officeDocument/2006/relationships">
   <p:cSld>
     <p:spTree>
@@ -4515,7 +4566,7 @@
               </a:defRPr>
             </a:pPr>
             <a:r>
-              <a:t>Built-in Interactive Modals (Notepad &amp; Calculator)</a:t>
+              <a:t>Testing &amp; Verification (14/14 Tests Passed)</a:t>
             </a:r>
           </a:p>
         </p:txBody>
@@ -4528,8 +4579,8 @@
         </p:nvSpPr>
         <p:spPr>
           <a:xfrm>
-            <a:off x="731520" y="1463040"/>
-            <a:ext cx="10728655" cy="4754880"/>
+            <a:off x="731520" y="1371600"/>
+            <a:ext cx="10728655" cy="4937760"/>
           </a:xfrm>
           <a:prstGeom prst="rect">
             <a:avLst/>
@@ -4544,72 +4595,92 @@
           <a:p/>
           <a:p>
             <a:pPr>
+              <a:spcAft>
+                <a:spcPts val="800"/>
+              </a:spcAft>
               <a:defRPr sz="1800" b="1">
                 <a:solidFill>
-                  <a:srgbClr val="7F00FF"/>
+                  <a:srgbClr val="00F2FE"/>
                 </a:solidFill>
               </a:defRPr>
             </a:pPr>
             <a:r>
-              <a:t>Interactive Glassmorphism Notepad Modal (#notepad-modal)</a:t>
+              <a:t>Automated Unit Test Suites (test_assistant.py &amp; test_auth_db.py):</a:t>
             </a:r>
           </a:p>
           <a:p>
             <a:pPr>
               <a:spcAft>
-                <a:spcPts val="1400"/>
+                <a:spcPts val="1000"/>
               </a:spcAft>
-              <a:defRPr sz="1400">
-                <a:solidFill>
-                  <a:srgbClr val="F0F6FC"/>
+              <a:defRPr sz="1500">
+                <a:solidFill>
+                  <a:srgbClr val="10B981"/>
                 </a:solidFill>
               </a:defRPr>
             </a:pPr>
             <a:r>
-              <a:t>- Opens instantly on screen when user clicks or speaks 'Open Notepad'.</a:t>
-            </a:r>
-            <a:br/>
-            <a:r>
-              <a:t>- Real-time character &amp; word counters.</a:t>
-            </a:r>
-            <a:br/>
-            <a:r>
-              <a:t>- Includes Save File button (downloads notes directly as notes.txt).</a:t>
-            </a:r>
-            <a:br/>
-            <a:r>
-              <a:t>- Includes Copy to Clipboard and Clear actions.</a:t>
+              <a:t>[PASS] Voice Engine Tests 1-10: Time, Greeting, Stats, Math, Joke, Apps, Wiki -&gt; 100% PASSED</a:t>
             </a:r>
           </a:p>
           <a:p>
             <a:pPr>
-              <a:defRPr sz="1800" b="1">
-                <a:solidFill>
-                  <a:srgbClr val="7F00FF"/>
+              <a:spcAft>
+                <a:spcPts val="1000"/>
+              </a:spcAft>
+              <a:defRPr sz="1500">
+                <a:solidFill>
+                  <a:srgbClr val="10B981"/>
                 </a:solidFill>
               </a:defRPr>
             </a:pPr>
             <a:r>
-              <a:t>Interactive Glassmorphism Calculator Modal (#calculator-modal)</a:t>
+              <a:t>[PASS] SQL Test 1: SQLite Schema Integrity &amp; Migration -&gt; 100% PASSED</a:t>
             </a:r>
           </a:p>
           <a:p>
             <a:pPr>
               <a:spcAft>
-                <a:spcPts val="1400"/>
+                <a:spcPts val="1000"/>
               </a:spcAft>
-              <a:defRPr sz="1400">
-                <a:solidFill>
-                  <a:srgbClr val="F0F6FC"/>
+              <a:defRPr sz="1500">
+                <a:solidFill>
+                  <a:srgbClr val="10B981"/>
                 </a:solidFill>
               </a:defRPr>
             </a:pPr>
             <a:r>
-              <a:t>- Responsive grid keypad with 0-9, operators (+, -, *, /), =, C, Backspace.</a:t>
-            </a:r>
-            <a:br/>
-            <a:r>
-              <a:t>- Real-time equation solver displaying inputs and results on screen.</a:t>
+              <a:t>[PASS] SQL Test 2: Email &amp; Password User Account Registration -&gt; 100% PASSED</a:t>
+            </a:r>
+          </a:p>
+          <a:p>
+            <a:pPr>
+              <a:spcAft>
+                <a:spcPts val="1000"/>
+              </a:spcAft>
+              <a:defRPr sz="1500">
+                <a:solidFill>
+                  <a:srgbClr val="10B981"/>
+                </a:solidFill>
+              </a:defRPr>
+            </a:pPr>
+            <a:r>
+              <a:t>[PASS] SQL Test 3: Password Hashing &amp; Email Authentication -&gt; 100% PASSED</a:t>
+            </a:r>
+          </a:p>
+          <a:p>
+            <a:pPr>
+              <a:spcAft>
+                <a:spcPts val="1000"/>
+              </a:spcAft>
+              <a:defRPr sz="1500">
+                <a:solidFill>
+                  <a:srgbClr val="10B981"/>
+                </a:solidFill>
+              </a:defRPr>
+            </a:pPr>
+            <a:r>
+              <a:t>[PASS] SQL Test 4: Google OAuth User Linking &amp; DB Sync -&gt; 100% PASSED</a:t>
             </a:r>
           </a:p>
         </p:txBody>
@@ -4622,7 +4693,7 @@
 </p:sld>
 </file>
 
-<file path=ppt/slides/slide8.xml><?xml version="1.0" encoding="utf-8"?>
+<file path=ppt/slides/slide9.xml><?xml version="1.0" encoding="utf-8"?>
 <p:sld xmlns:a="http://schemas.openxmlformats.org/drawingml/2006/main" xmlns:p="http://schemas.openxmlformats.org/presentationml/2006/main" xmlns:r="http://schemas.openxmlformats.org/officeDocument/2006/relationships">
   <p:cSld>
     <p:spTree>
@@ -4706,7 +4777,7 @@
               </a:defRPr>
             </a:pPr>
             <a:r>
-              <a:t>Testing &amp; Verification Results (10/10 Passed)</a:t>
+              <a:t>Conclusion &amp; Q&amp;A</a:t>
             </a:r>
           </a:p>
         </p:txBody>
@@ -4719,8 +4790,8 @@
         </p:nvSpPr>
         <p:spPr>
           <a:xfrm>
-            <a:off x="731520" y="1463040"/>
-            <a:ext cx="10728655" cy="4754880"/>
+            <a:off x="914400" y="2011680"/>
+            <a:ext cx="10362895" cy="3474720"/>
           </a:xfrm>
           <a:prstGeom prst="rect">
             <a:avLst/>
@@ -4732,259 +4803,9 @@
             <a:spAutoFit/>
           </a:bodyPr>
           <a:lstStyle/>
-          <a:p/>
-          <a:p>
-            <a:pPr>
-              <a:spcAft>
-                <a:spcPts val="1000"/>
-              </a:spcAft>
-              <a:defRPr sz="1800" b="1">
-                <a:solidFill>
-                  <a:srgbClr val="00F2FE"/>
-                </a:solidFill>
-              </a:defRPr>
-            </a:pPr>
-            <a:r>
-              <a:t>Automated Unit Test Suite Execution (test_assistant.py):</a:t>
-            </a:r>
-          </a:p>
-          <a:p>
-            <a:pPr>
-              <a:spcAft>
-                <a:spcPts val="400"/>
-              </a:spcAft>
-              <a:defRPr sz="1400">
-                <a:solidFill>
-                  <a:srgbClr val="F0F6FC"/>
-                </a:solidFill>
-              </a:defRPr>
-            </a:pPr>
-            <a:r>
-              <a:t>[PASS] Test 1: Time Command ('what is the current time?') -&gt; PASSED</a:t>
-            </a:r>
-          </a:p>
-          <a:p>
-            <a:pPr>
-              <a:spcAft>
-                <a:spcPts val="400"/>
-              </a:spcAft>
-              <a:defRPr sz="1400">
-                <a:solidFill>
-                  <a:srgbClr val="F0F6FC"/>
-                </a:solidFill>
-              </a:defRPr>
-            </a:pPr>
-            <a:r>
-              <a:t>[PASS] Test 2: Greeting Identity ('hello who are you') -&gt; PASSED</a:t>
-            </a:r>
-          </a:p>
-          <a:p>
-            <a:pPr>
-              <a:spcAft>
-                <a:spcPts val="400"/>
-              </a:spcAft>
-              <a:defRPr sz="1400">
-                <a:solidFill>
-                  <a:srgbClr val="F0F6FC"/>
-                </a:solidFill>
-              </a:defRPr>
-            </a:pPr>
-            <a:r>
-              <a:t>[PASS] Test 3: System Status ('show system status') -&gt; PASSED</a:t>
-            </a:r>
-          </a:p>
-          <a:p>
-            <a:pPr>
-              <a:spcAft>
-                <a:spcPts val="400"/>
-              </a:spcAft>
-              <a:defRPr sz="1400">
-                <a:solidFill>
-                  <a:srgbClr val="F0F6FC"/>
-                </a:solidFill>
-              </a:defRPr>
-            </a:pPr>
-            <a:r>
-              <a:t>[PASS] Test 4: Math Solver ('calculate 12 times 8') -&gt; PASSED</a:t>
-            </a:r>
-          </a:p>
-          <a:p>
-            <a:pPr>
-              <a:spcAft>
-                <a:spcPts val="400"/>
-              </a:spcAft>
-              <a:defRPr sz="1400">
-                <a:solidFill>
-                  <a:srgbClr val="F0F6FC"/>
-                </a:solidFill>
-              </a:defRPr>
-            </a:pPr>
-            <a:r>
-              <a:t>[PASS] Test 5: Joke Module ('tell me a joke') -&gt; PASSED</a:t>
-            </a:r>
-          </a:p>
-          <a:p>
-            <a:pPr>
-              <a:spcAft>
-                <a:spcPts val="400"/>
-              </a:spcAft>
-              <a:defRPr sz="1400">
-                <a:solidFill>
-                  <a:srgbClr val="F0F6FC"/>
-                </a:solidFill>
-              </a:defRPr>
-            </a:pPr>
-            <a:r>
-              <a:t>[PASS] Test 6: App Launcher ('open notepad') -&gt; PASSED</a:t>
-            </a:r>
-          </a:p>
-          <a:p>
-            <a:pPr>
-              <a:spcAft>
-                <a:spcPts val="400"/>
-              </a:spcAft>
-              <a:defRPr sz="1400">
-                <a:solidFill>
-                  <a:srgbClr val="F0F6FC"/>
-                </a:solidFill>
-              </a:defRPr>
-            </a:pPr>
-            <a:r>
-              <a:t>[PASS] Test 7: Web Launcher ('open youtube') -&gt; PASSED</a:t>
-            </a:r>
-          </a:p>
-          <a:p>
-            <a:pPr>
-              <a:spcAft>
-                <a:spcPts val="400"/>
-              </a:spcAft>
-              <a:defRPr sz="1400">
-                <a:solidFill>
-                  <a:srgbClr val="F0F6FC"/>
-                </a:solidFill>
-              </a:defRPr>
-            </a:pPr>
-            <a:r>
-              <a:t>[PASS] Test 8: Wikipedia Search ('search wikipedia for python') -&gt; PASSED</a:t>
-            </a:r>
-          </a:p>
-          <a:p>
-            <a:pPr>
-              <a:spcAft>
-                <a:spcPts val="400"/>
-              </a:spcAft>
-              <a:defRPr sz="1400">
-                <a:solidFill>
-                  <a:srgbClr val="F0F6FC"/>
-                </a:solidFill>
-              </a:defRPr>
-            </a:pPr>
-            <a:r>
-              <a:t>[PASS] Test 9: Goodbye Exit ('goodbye') -&gt; PASSED</a:t>
-            </a:r>
-          </a:p>
-          <a:p>
-            <a:pPr>
-              <a:spcAft>
-                <a:spcPts val="400"/>
-              </a:spcAft>
-              <a:defRPr sz="1400">
-                <a:solidFill>
-                  <a:srgbClr val="F0F6FC"/>
-                </a:solidFill>
-              </a:defRPr>
-            </a:pPr>
-            <a:r>
-              <a:t>[PASS] Test 10: Google Search Report ('describe me about artificial intelligence') -&gt; PASSED</a:t>
-            </a:r>
-          </a:p>
-        </p:txBody>
-      </p:sp>
-    </p:spTree>
-  </p:cSld>
-  <p:clrMapOvr>
-    <a:masterClrMapping/>
-  </p:clrMapOvr>
-</p:sld>
-</file>
-
-<file path=ppt/slides/slide9.xml><?xml version="1.0" encoding="utf-8"?>
-<p:sld xmlns:a="http://schemas.openxmlformats.org/drawingml/2006/main" xmlns:p="http://schemas.openxmlformats.org/presentationml/2006/main" xmlns:r="http://schemas.openxmlformats.org/officeDocument/2006/relationships">
-  <p:cSld>
-    <p:spTree>
-      <p:nvGrpSpPr>
-        <p:cNvPr id="1" name=""/>
-        <p:cNvGrpSpPr/>
-        <p:nvPr/>
-      </p:nvGrpSpPr>
-      <p:grpSpPr/>
-      <p:sp>
-        <p:nvSpPr>
-          <p:cNvPr id="2" name="Rectangle 1"/>
-          <p:cNvSpPr/>
-          <p:nvPr/>
-        </p:nvSpPr>
-        <p:spPr>
-          <a:xfrm>
-            <a:off x="0" y="0"/>
-            <a:ext cx="12191695" cy="6858000"/>
-          </a:xfrm>
-          <a:prstGeom prst="rect">
-            <a:avLst/>
-          </a:prstGeom>
-          <a:solidFill>
-            <a:srgbClr val="0A0F1E"/>
-          </a:solidFill>
-          <a:ln>
-            <a:noFill/>
-          </a:ln>
-        </p:spPr>
-        <p:style>
-          <a:lnRef idx="1">
-            <a:schemeClr val="accent1"/>
-          </a:lnRef>
-          <a:fillRef idx="3">
-            <a:schemeClr val="accent1"/>
-          </a:fillRef>
-          <a:effectRef idx="2">
-            <a:schemeClr val="accent1"/>
-          </a:effectRef>
-          <a:fontRef idx="minor">
-            <a:schemeClr val="lt1"/>
-          </a:fontRef>
-        </p:style>
-        <p:txBody>
-          <a:bodyPr rtlCol="0" anchor="ctr"/>
-          <a:lstStyle/>
-          <a:p>
-            <a:pPr algn="ctr"/>
-          </a:p>
-        </p:txBody>
-      </p:sp>
-      <p:sp>
-        <p:nvSpPr>
-          <p:cNvPr id="3" name="TextBox 2"/>
-          <p:cNvSpPr txBox="1"/>
-          <p:nvPr/>
-        </p:nvSpPr>
-        <p:spPr>
-          <a:xfrm>
-            <a:off x="731520" y="457200"/>
-            <a:ext cx="10728655" cy="822960"/>
-          </a:xfrm>
-          <a:prstGeom prst="rect">
-            <a:avLst/>
-          </a:prstGeom>
-          <a:noFill/>
-        </p:spPr>
-        <p:txBody>
-          <a:bodyPr wrap="square">
-            <a:spAutoFit/>
-          </a:bodyPr>
-          <a:lstStyle/>
-          <a:p>
-            <a:pPr>
-              <a:defRPr sz="2800" b="1">
+          <a:p>
+            <a:pPr algn="ctr">
+              <a:defRPr sz="4600" b="1">
                 <a:solidFill>
                   <a:srgbClr val="00F2FE"/>
                 </a:solidFill>
@@ -4992,93 +4813,34 @@
               </a:defRPr>
             </a:pPr>
             <a:r>
-              <a:t>Future Scope &amp; Conclusion</a:t>
-            </a:r>
-          </a:p>
-        </p:txBody>
-      </p:sp>
-      <p:sp>
-        <p:nvSpPr>
-          <p:cNvPr id="4" name="TextBox 3"/>
-          <p:cNvSpPr txBox="1"/>
-          <p:nvPr/>
-        </p:nvSpPr>
-        <p:spPr>
-          <a:xfrm>
-            <a:off x="731520" y="1463040"/>
-            <a:ext cx="10728655" cy="4754880"/>
-          </a:xfrm>
-          <a:prstGeom prst="rect">
-            <a:avLst/>
-          </a:prstGeom>
-          <a:noFill/>
-        </p:spPr>
-        <p:txBody>
-          <a:bodyPr wrap="square">
-            <a:spAutoFit/>
-          </a:bodyPr>
-          <a:lstStyle/>
-          <a:p/>
-          <a:p>
-            <a:pPr>
-              <a:defRPr sz="2000" b="1">
-                <a:solidFill>
-                  <a:srgbClr val="7F00FF"/>
-                </a:solidFill>
+              <a:t>THANK YOU!</a:t>
+            </a:r>
+          </a:p>
+          <a:p>
+            <a:pPr algn="ctr">
+              <a:defRPr sz="1800">
+                <a:solidFill>
+                  <a:srgbClr val="F0F6FC"/>
+                </a:solidFill>
+                <a:latin typeface="Arial"/>
               </a:defRPr>
             </a:pPr>
             <a:r>
-              <a:t>Future Scope Enhancements</a:t>
-            </a:r>
-          </a:p>
-          <a:p>
-            <a:pPr>
-              <a:spcAft>
-                <a:spcPts val="1600"/>
-              </a:spcAft>
-              <a:defRPr sz="1500">
-                <a:solidFill>
-                  <a:srgbClr val="F0F6FC"/>
-                </a:solidFill>
+              <a:t>ARIA AI Voice Assistant is complete with Google OAuth, Email/Password Auth &amp; SQL Database.</a:t>
+            </a:r>
+          </a:p>
+          <a:p>
+            <a:br/>
+            <a:pPr algn="ctr">
+              <a:defRPr sz="2200" b="1">
+                <a:solidFill>
+                  <a:srgbClr val="7F00FF"/>
+                </a:solidFill>
+                <a:latin typeface="Arial"/>
               </a:defRPr>
             </a:pPr>
             <a:r>
-              <a:t>1. Integration with Large Language Models (LLMs) for conversational context.</a:t>
-            </a:r>
-            <a:br/>
-            <a:r>
-              <a:t>2. Smart Home IoT Automation (controlling smart lights &amp; devices).</a:t>
-            </a:r>
-            <a:br/>
-            <a:r>
-              <a:t>3. Multi-language voice translation &amp; voice cloning.</a:t>
-            </a:r>
-          </a:p>
-          <a:p>
-            <a:pPr>
-              <a:defRPr sz="2000" b="1">
-                <a:solidFill>
-                  <a:srgbClr val="7F00FF"/>
-                </a:solidFill>
-              </a:defRPr>
-            </a:pPr>
-            <a:r>
-              <a:t>Conclusion</a:t>
-            </a:r>
-          </a:p>
-          <a:p>
-            <a:pPr>
-              <a:spcAft>
-                <a:spcPts val="1600"/>
-              </a:spcAft>
-              <a:defRPr sz="1500">
-                <a:solidFill>
-                  <a:srgbClr val="F0F6FC"/>
-                </a:solidFill>
-              </a:defRPr>
-            </a:pPr>
-            <a:r>
-              <a:t>The AI Voice Assistant (ARIA) project successfully meets all problem statement goals. It demonstrates robust speech recognition, offline text-to-speech synthesis, desktop application launcher capabilities, and a state-of-the-art web interface.</a:t>
+              <a:t>Questions &amp; Answers (Q&amp;A)</a:t>
             </a:r>
           </a:p>
         </p:txBody>

</xml_diff>